<commit_message>
Update ecosystem image to reflect move to github
</commit_message>
<xml_diff>
--- a/resources/Ecosystem.pptx
+++ b/resources/Ecosystem.pptx
@@ -154,7 +154,7 @@
           </a:lstStyle>
           <a:p>
             <a:r>
-              <a:rPr lang="de-DE" smtClean="0"/>
+              <a:rPr lang="de-DE"/>
               <a:t>Titelmasterformat durch Klicken bearbeiten</a:t>
             </a:r>
             <a:endParaRPr lang="en-GB"/>
@@ -219,7 +219,7 @@
           </a:lstStyle>
           <a:p>
             <a:r>
-              <a:rPr lang="de-DE" smtClean="0"/>
+              <a:rPr lang="de-DE"/>
               <a:t>Formatvorlage des Untertitelmasters durch Klicken bearbeiten</a:t>
             </a:r>
             <a:endParaRPr lang="en-GB"/>
@@ -243,7 +243,7 @@
           <a:p>
             <a:fld id="{3FB75DC4-049D-4A9B-B286-BF003F86F273}" type="datetimeFigureOut">
               <a:rPr lang="en-GB" smtClean="0"/>
-              <a:t>30/10/2021</a:t>
+              <a:t>23/06/2025</a:t>
             </a:fld>
             <a:endParaRPr lang="en-GB" dirty="0"/>
           </a:p>
@@ -285,7 +285,7 @@
           <a:p>
             <a:fld id="{28392D24-8B86-4B92-BF71-2898FDE196EB}" type="slidenum">
               <a:rPr lang="en-GB" smtClean="0"/>
-              <a:t>‹Nr.›</a:t>
+              <a:t>‹#›</a:t>
             </a:fld>
             <a:endParaRPr lang="en-GB" dirty="0"/>
           </a:p>
@@ -337,7 +337,7 @@
           <a:lstStyle/>
           <a:p>
             <a:r>
-              <a:rPr lang="de-DE" smtClean="0"/>
+              <a:rPr lang="de-DE"/>
               <a:t>Titelmasterformat durch Klicken bearbeiten</a:t>
             </a:r>
             <a:endParaRPr lang="en-GB"/>
@@ -361,35 +361,35 @@
           <a:p>
             <a:pPr lvl="0"/>
             <a:r>
-              <a:rPr lang="de-DE" smtClean="0"/>
+              <a:rPr lang="de-DE"/>
               <a:t>Textmasterformat bearbeiten</a:t>
             </a:r>
           </a:p>
           <a:p>
             <a:pPr lvl="1"/>
             <a:r>
-              <a:rPr lang="de-DE" smtClean="0"/>
+              <a:rPr lang="de-DE"/>
               <a:t>Zweite Ebene</a:t>
             </a:r>
           </a:p>
           <a:p>
             <a:pPr lvl="2"/>
             <a:r>
-              <a:rPr lang="de-DE" smtClean="0"/>
+              <a:rPr lang="de-DE"/>
               <a:t>Dritte Ebene</a:t>
             </a:r>
           </a:p>
           <a:p>
             <a:pPr lvl="3"/>
             <a:r>
-              <a:rPr lang="de-DE" smtClean="0"/>
+              <a:rPr lang="de-DE"/>
               <a:t>Vierte Ebene</a:t>
             </a:r>
           </a:p>
           <a:p>
             <a:pPr lvl="4"/>
             <a:r>
-              <a:rPr lang="de-DE" smtClean="0"/>
+              <a:rPr lang="de-DE"/>
               <a:t>Fünfte Ebene</a:t>
             </a:r>
             <a:endParaRPr lang="en-GB"/>
@@ -413,7 +413,7 @@
           <a:p>
             <a:fld id="{3FB75DC4-049D-4A9B-B286-BF003F86F273}" type="datetimeFigureOut">
               <a:rPr lang="en-GB" smtClean="0"/>
-              <a:t>30/10/2021</a:t>
+              <a:t>23/06/2025</a:t>
             </a:fld>
             <a:endParaRPr lang="en-GB" dirty="0"/>
           </a:p>
@@ -455,7 +455,7 @@
           <a:p>
             <a:fld id="{28392D24-8B86-4B92-BF71-2898FDE196EB}" type="slidenum">
               <a:rPr lang="en-GB" smtClean="0"/>
-              <a:t>‹Nr.›</a:t>
+              <a:t>‹#›</a:t>
             </a:fld>
             <a:endParaRPr lang="en-GB" dirty="0"/>
           </a:p>
@@ -512,7 +512,7 @@
           <a:lstStyle/>
           <a:p>
             <a:r>
-              <a:rPr lang="de-DE" smtClean="0"/>
+              <a:rPr lang="de-DE"/>
               <a:t>Titelmasterformat durch Klicken bearbeiten</a:t>
             </a:r>
             <a:endParaRPr lang="en-GB"/>
@@ -541,35 +541,35 @@
           <a:p>
             <a:pPr lvl="0"/>
             <a:r>
-              <a:rPr lang="de-DE" smtClean="0"/>
+              <a:rPr lang="de-DE"/>
               <a:t>Textmasterformat bearbeiten</a:t>
             </a:r>
           </a:p>
           <a:p>
             <a:pPr lvl="1"/>
             <a:r>
-              <a:rPr lang="de-DE" smtClean="0"/>
+              <a:rPr lang="de-DE"/>
               <a:t>Zweite Ebene</a:t>
             </a:r>
           </a:p>
           <a:p>
             <a:pPr lvl="2"/>
             <a:r>
-              <a:rPr lang="de-DE" smtClean="0"/>
+              <a:rPr lang="de-DE"/>
               <a:t>Dritte Ebene</a:t>
             </a:r>
           </a:p>
           <a:p>
             <a:pPr lvl="3"/>
             <a:r>
-              <a:rPr lang="de-DE" smtClean="0"/>
+              <a:rPr lang="de-DE"/>
               <a:t>Vierte Ebene</a:t>
             </a:r>
           </a:p>
           <a:p>
             <a:pPr lvl="4"/>
             <a:r>
-              <a:rPr lang="de-DE" smtClean="0"/>
+              <a:rPr lang="de-DE"/>
               <a:t>Fünfte Ebene</a:t>
             </a:r>
             <a:endParaRPr lang="en-GB"/>
@@ -593,7 +593,7 @@
           <a:p>
             <a:fld id="{3FB75DC4-049D-4A9B-B286-BF003F86F273}" type="datetimeFigureOut">
               <a:rPr lang="en-GB" smtClean="0"/>
-              <a:t>30/10/2021</a:t>
+              <a:t>23/06/2025</a:t>
             </a:fld>
             <a:endParaRPr lang="en-GB" dirty="0"/>
           </a:p>
@@ -635,7 +635,7 @@
           <a:p>
             <a:fld id="{28392D24-8B86-4B92-BF71-2898FDE196EB}" type="slidenum">
               <a:rPr lang="en-GB" smtClean="0"/>
-              <a:t>‹Nr.›</a:t>
+              <a:t>‹#›</a:t>
             </a:fld>
             <a:endParaRPr lang="en-GB" dirty="0"/>
           </a:p>
@@ -687,7 +687,7 @@
           <a:lstStyle/>
           <a:p>
             <a:r>
-              <a:rPr lang="de-DE" smtClean="0"/>
+              <a:rPr lang="de-DE"/>
               <a:t>Titelmasterformat durch Klicken bearbeiten</a:t>
             </a:r>
             <a:endParaRPr lang="en-GB"/>
@@ -711,35 +711,35 @@
           <a:p>
             <a:pPr lvl="0"/>
             <a:r>
-              <a:rPr lang="de-DE" smtClean="0"/>
+              <a:rPr lang="de-DE"/>
               <a:t>Textmasterformat bearbeiten</a:t>
             </a:r>
           </a:p>
           <a:p>
             <a:pPr lvl="1"/>
             <a:r>
-              <a:rPr lang="de-DE" smtClean="0"/>
+              <a:rPr lang="de-DE"/>
               <a:t>Zweite Ebene</a:t>
             </a:r>
           </a:p>
           <a:p>
             <a:pPr lvl="2"/>
             <a:r>
-              <a:rPr lang="de-DE" smtClean="0"/>
+              <a:rPr lang="de-DE"/>
               <a:t>Dritte Ebene</a:t>
             </a:r>
           </a:p>
           <a:p>
             <a:pPr lvl="3"/>
             <a:r>
-              <a:rPr lang="de-DE" smtClean="0"/>
+              <a:rPr lang="de-DE"/>
               <a:t>Vierte Ebene</a:t>
             </a:r>
           </a:p>
           <a:p>
             <a:pPr lvl="4"/>
             <a:r>
-              <a:rPr lang="de-DE" smtClean="0"/>
+              <a:rPr lang="de-DE"/>
               <a:t>Fünfte Ebene</a:t>
             </a:r>
             <a:endParaRPr lang="en-GB"/>
@@ -763,7 +763,7 @@
           <a:p>
             <a:fld id="{3FB75DC4-049D-4A9B-B286-BF003F86F273}" type="datetimeFigureOut">
               <a:rPr lang="en-GB" smtClean="0"/>
-              <a:t>30/10/2021</a:t>
+              <a:t>23/06/2025</a:t>
             </a:fld>
             <a:endParaRPr lang="en-GB" dirty="0"/>
           </a:p>
@@ -805,7 +805,7 @@
           <a:p>
             <a:fld id="{28392D24-8B86-4B92-BF71-2898FDE196EB}" type="slidenum">
               <a:rPr lang="en-GB" smtClean="0"/>
-              <a:t>‹Nr.›</a:t>
+              <a:t>‹#›</a:t>
             </a:fld>
             <a:endParaRPr lang="en-GB" dirty="0"/>
           </a:p>
@@ -866,7 +866,7 @@
           </a:lstStyle>
           <a:p>
             <a:r>
-              <a:rPr lang="de-DE" smtClean="0"/>
+              <a:rPr lang="de-DE"/>
               <a:t>Titelmasterformat durch Klicken bearbeiten</a:t>
             </a:r>
             <a:endParaRPr lang="en-GB"/>
@@ -986,7 +986,7 @@
           <a:p>
             <a:pPr lvl="0"/>
             <a:r>
-              <a:rPr lang="de-DE" smtClean="0"/>
+              <a:rPr lang="de-DE"/>
               <a:t>Textmasterformat bearbeiten</a:t>
             </a:r>
           </a:p>
@@ -1009,7 +1009,7 @@
           <a:p>
             <a:fld id="{3FB75DC4-049D-4A9B-B286-BF003F86F273}" type="datetimeFigureOut">
               <a:rPr lang="en-GB" smtClean="0"/>
-              <a:t>30/10/2021</a:t>
+              <a:t>23/06/2025</a:t>
             </a:fld>
             <a:endParaRPr lang="en-GB" dirty="0"/>
           </a:p>
@@ -1051,7 +1051,7 @@
           <a:p>
             <a:fld id="{28392D24-8B86-4B92-BF71-2898FDE196EB}" type="slidenum">
               <a:rPr lang="en-GB" smtClean="0"/>
-              <a:t>‹Nr.›</a:t>
+              <a:t>‹#›</a:t>
             </a:fld>
             <a:endParaRPr lang="en-GB" dirty="0"/>
           </a:p>
@@ -1103,7 +1103,7 @@
           <a:lstStyle/>
           <a:p>
             <a:r>
-              <a:rPr lang="de-DE" smtClean="0"/>
+              <a:rPr lang="de-DE"/>
               <a:t>Titelmasterformat durch Klicken bearbeiten</a:t>
             </a:r>
             <a:endParaRPr lang="en-GB"/>
@@ -1132,35 +1132,35 @@
           <a:p>
             <a:pPr lvl="0"/>
             <a:r>
-              <a:rPr lang="de-DE" smtClean="0"/>
+              <a:rPr lang="de-DE"/>
               <a:t>Textmasterformat bearbeiten</a:t>
             </a:r>
           </a:p>
           <a:p>
             <a:pPr lvl="1"/>
             <a:r>
-              <a:rPr lang="de-DE" smtClean="0"/>
+              <a:rPr lang="de-DE"/>
               <a:t>Zweite Ebene</a:t>
             </a:r>
           </a:p>
           <a:p>
             <a:pPr lvl="2"/>
             <a:r>
-              <a:rPr lang="de-DE" smtClean="0"/>
+              <a:rPr lang="de-DE"/>
               <a:t>Dritte Ebene</a:t>
             </a:r>
           </a:p>
           <a:p>
             <a:pPr lvl="3"/>
             <a:r>
-              <a:rPr lang="de-DE" smtClean="0"/>
+              <a:rPr lang="de-DE"/>
               <a:t>Vierte Ebene</a:t>
             </a:r>
           </a:p>
           <a:p>
             <a:pPr lvl="4"/>
             <a:r>
-              <a:rPr lang="de-DE" smtClean="0"/>
+              <a:rPr lang="de-DE"/>
               <a:t>Fünfte Ebene</a:t>
             </a:r>
             <a:endParaRPr lang="en-GB"/>
@@ -1189,35 +1189,35 @@
           <a:p>
             <a:pPr lvl="0"/>
             <a:r>
-              <a:rPr lang="de-DE" smtClean="0"/>
+              <a:rPr lang="de-DE"/>
               <a:t>Textmasterformat bearbeiten</a:t>
             </a:r>
           </a:p>
           <a:p>
             <a:pPr lvl="1"/>
             <a:r>
-              <a:rPr lang="de-DE" smtClean="0"/>
+              <a:rPr lang="de-DE"/>
               <a:t>Zweite Ebene</a:t>
             </a:r>
           </a:p>
           <a:p>
             <a:pPr lvl="2"/>
             <a:r>
-              <a:rPr lang="de-DE" smtClean="0"/>
+              <a:rPr lang="de-DE"/>
               <a:t>Dritte Ebene</a:t>
             </a:r>
           </a:p>
           <a:p>
             <a:pPr lvl="3"/>
             <a:r>
-              <a:rPr lang="de-DE" smtClean="0"/>
+              <a:rPr lang="de-DE"/>
               <a:t>Vierte Ebene</a:t>
             </a:r>
           </a:p>
           <a:p>
             <a:pPr lvl="4"/>
             <a:r>
-              <a:rPr lang="de-DE" smtClean="0"/>
+              <a:rPr lang="de-DE"/>
               <a:t>Fünfte Ebene</a:t>
             </a:r>
             <a:endParaRPr lang="en-GB"/>
@@ -1241,7 +1241,7 @@
           <a:p>
             <a:fld id="{3FB75DC4-049D-4A9B-B286-BF003F86F273}" type="datetimeFigureOut">
               <a:rPr lang="en-GB" smtClean="0"/>
-              <a:t>30/10/2021</a:t>
+              <a:t>23/06/2025</a:t>
             </a:fld>
             <a:endParaRPr lang="en-GB" dirty="0"/>
           </a:p>
@@ -1283,7 +1283,7 @@
           <a:p>
             <a:fld id="{28392D24-8B86-4B92-BF71-2898FDE196EB}" type="slidenum">
               <a:rPr lang="en-GB" smtClean="0"/>
-              <a:t>‹Nr.›</a:t>
+              <a:t>‹#›</a:t>
             </a:fld>
             <a:endParaRPr lang="en-GB" dirty="0"/>
           </a:p>
@@ -1340,7 +1340,7 @@
           <a:lstStyle/>
           <a:p>
             <a:r>
-              <a:rPr lang="de-DE" smtClean="0"/>
+              <a:rPr lang="de-DE"/>
               <a:t>Titelmasterformat durch Klicken bearbeiten</a:t>
             </a:r>
             <a:endParaRPr lang="en-GB"/>
@@ -1406,7 +1406,7 @@
           <a:p>
             <a:pPr lvl="0"/>
             <a:r>
-              <a:rPr lang="de-DE" smtClean="0"/>
+              <a:rPr lang="de-DE"/>
               <a:t>Textmasterformat bearbeiten</a:t>
             </a:r>
           </a:p>
@@ -1434,35 +1434,35 @@
           <a:p>
             <a:pPr lvl="0"/>
             <a:r>
-              <a:rPr lang="de-DE" smtClean="0"/>
+              <a:rPr lang="de-DE"/>
               <a:t>Textmasterformat bearbeiten</a:t>
             </a:r>
           </a:p>
           <a:p>
             <a:pPr lvl="1"/>
             <a:r>
-              <a:rPr lang="de-DE" smtClean="0"/>
+              <a:rPr lang="de-DE"/>
               <a:t>Zweite Ebene</a:t>
             </a:r>
           </a:p>
           <a:p>
             <a:pPr lvl="2"/>
             <a:r>
-              <a:rPr lang="de-DE" smtClean="0"/>
+              <a:rPr lang="de-DE"/>
               <a:t>Dritte Ebene</a:t>
             </a:r>
           </a:p>
           <a:p>
             <a:pPr lvl="3"/>
             <a:r>
-              <a:rPr lang="de-DE" smtClean="0"/>
+              <a:rPr lang="de-DE"/>
               <a:t>Vierte Ebene</a:t>
             </a:r>
           </a:p>
           <a:p>
             <a:pPr lvl="4"/>
             <a:r>
-              <a:rPr lang="de-DE" smtClean="0"/>
+              <a:rPr lang="de-DE"/>
               <a:t>Fünfte Ebene</a:t>
             </a:r>
             <a:endParaRPr lang="en-GB"/>
@@ -1528,7 +1528,7 @@
           <a:p>
             <a:pPr lvl="0"/>
             <a:r>
-              <a:rPr lang="de-DE" smtClean="0"/>
+              <a:rPr lang="de-DE"/>
               <a:t>Textmasterformat bearbeiten</a:t>
             </a:r>
           </a:p>
@@ -1556,35 +1556,35 @@
           <a:p>
             <a:pPr lvl="0"/>
             <a:r>
-              <a:rPr lang="de-DE" smtClean="0"/>
+              <a:rPr lang="de-DE"/>
               <a:t>Textmasterformat bearbeiten</a:t>
             </a:r>
           </a:p>
           <a:p>
             <a:pPr lvl="1"/>
             <a:r>
-              <a:rPr lang="de-DE" smtClean="0"/>
+              <a:rPr lang="de-DE"/>
               <a:t>Zweite Ebene</a:t>
             </a:r>
           </a:p>
           <a:p>
             <a:pPr lvl="2"/>
             <a:r>
-              <a:rPr lang="de-DE" smtClean="0"/>
+              <a:rPr lang="de-DE"/>
               <a:t>Dritte Ebene</a:t>
             </a:r>
           </a:p>
           <a:p>
             <a:pPr lvl="3"/>
             <a:r>
-              <a:rPr lang="de-DE" smtClean="0"/>
+              <a:rPr lang="de-DE"/>
               <a:t>Vierte Ebene</a:t>
             </a:r>
           </a:p>
           <a:p>
             <a:pPr lvl="4"/>
             <a:r>
-              <a:rPr lang="de-DE" smtClean="0"/>
+              <a:rPr lang="de-DE"/>
               <a:t>Fünfte Ebene</a:t>
             </a:r>
             <a:endParaRPr lang="en-GB"/>
@@ -1608,7 +1608,7 @@
           <a:p>
             <a:fld id="{3FB75DC4-049D-4A9B-B286-BF003F86F273}" type="datetimeFigureOut">
               <a:rPr lang="en-GB" smtClean="0"/>
-              <a:t>30/10/2021</a:t>
+              <a:t>23/06/2025</a:t>
             </a:fld>
             <a:endParaRPr lang="en-GB" dirty="0"/>
           </a:p>
@@ -1650,7 +1650,7 @@
           <a:p>
             <a:fld id="{28392D24-8B86-4B92-BF71-2898FDE196EB}" type="slidenum">
               <a:rPr lang="en-GB" smtClean="0"/>
-              <a:t>‹Nr.›</a:t>
+              <a:t>‹#›</a:t>
             </a:fld>
             <a:endParaRPr lang="en-GB" dirty="0"/>
           </a:p>
@@ -1702,7 +1702,7 @@
           <a:lstStyle/>
           <a:p>
             <a:r>
-              <a:rPr lang="de-DE" smtClean="0"/>
+              <a:rPr lang="de-DE"/>
               <a:t>Titelmasterformat durch Klicken bearbeiten</a:t>
             </a:r>
             <a:endParaRPr lang="en-GB"/>
@@ -1726,7 +1726,7 @@
           <a:p>
             <a:fld id="{3FB75DC4-049D-4A9B-B286-BF003F86F273}" type="datetimeFigureOut">
               <a:rPr lang="en-GB" smtClean="0"/>
-              <a:t>30/10/2021</a:t>
+              <a:t>23/06/2025</a:t>
             </a:fld>
             <a:endParaRPr lang="en-GB" dirty="0"/>
           </a:p>
@@ -1768,7 +1768,7 @@
           <a:p>
             <a:fld id="{28392D24-8B86-4B92-BF71-2898FDE196EB}" type="slidenum">
               <a:rPr lang="en-GB" smtClean="0"/>
-              <a:t>‹Nr.›</a:t>
+              <a:t>‹#›</a:t>
             </a:fld>
             <a:endParaRPr lang="en-GB" dirty="0"/>
           </a:p>
@@ -1821,7 +1821,7 @@
           <a:p>
             <a:fld id="{3FB75DC4-049D-4A9B-B286-BF003F86F273}" type="datetimeFigureOut">
               <a:rPr lang="en-GB" smtClean="0"/>
-              <a:t>30/10/2021</a:t>
+              <a:t>23/06/2025</a:t>
             </a:fld>
             <a:endParaRPr lang="en-GB" dirty="0"/>
           </a:p>
@@ -1863,7 +1863,7 @@
           <a:p>
             <a:fld id="{28392D24-8B86-4B92-BF71-2898FDE196EB}" type="slidenum">
               <a:rPr lang="en-GB" smtClean="0"/>
-              <a:t>‹Nr.›</a:t>
+              <a:t>‹#›</a:t>
             </a:fld>
             <a:endParaRPr lang="en-GB" dirty="0"/>
           </a:p>
@@ -1924,7 +1924,7 @@
           </a:lstStyle>
           <a:p>
             <a:r>
-              <a:rPr lang="de-DE" smtClean="0"/>
+              <a:rPr lang="de-DE"/>
               <a:t>Titelmasterformat durch Klicken bearbeiten</a:t>
             </a:r>
             <a:endParaRPr lang="en-GB"/>
@@ -1981,35 +1981,35 @@
           <a:p>
             <a:pPr lvl="0"/>
             <a:r>
-              <a:rPr lang="de-DE" smtClean="0"/>
+              <a:rPr lang="de-DE"/>
               <a:t>Textmasterformat bearbeiten</a:t>
             </a:r>
           </a:p>
           <a:p>
             <a:pPr lvl="1"/>
             <a:r>
-              <a:rPr lang="de-DE" smtClean="0"/>
+              <a:rPr lang="de-DE"/>
               <a:t>Zweite Ebene</a:t>
             </a:r>
           </a:p>
           <a:p>
             <a:pPr lvl="2"/>
             <a:r>
-              <a:rPr lang="de-DE" smtClean="0"/>
+              <a:rPr lang="de-DE"/>
               <a:t>Dritte Ebene</a:t>
             </a:r>
           </a:p>
           <a:p>
             <a:pPr lvl="3"/>
             <a:r>
-              <a:rPr lang="de-DE" smtClean="0"/>
+              <a:rPr lang="de-DE"/>
               <a:t>Vierte Ebene</a:t>
             </a:r>
           </a:p>
           <a:p>
             <a:pPr lvl="4"/>
             <a:r>
-              <a:rPr lang="de-DE" smtClean="0"/>
+              <a:rPr lang="de-DE"/>
               <a:t>Fünfte Ebene</a:t>
             </a:r>
             <a:endParaRPr lang="en-GB"/>
@@ -2075,7 +2075,7 @@
           <a:p>
             <a:pPr lvl="0"/>
             <a:r>
-              <a:rPr lang="de-DE" smtClean="0"/>
+              <a:rPr lang="de-DE"/>
               <a:t>Textmasterformat bearbeiten</a:t>
             </a:r>
           </a:p>
@@ -2098,7 +2098,7 @@
           <a:p>
             <a:fld id="{3FB75DC4-049D-4A9B-B286-BF003F86F273}" type="datetimeFigureOut">
               <a:rPr lang="en-GB" smtClean="0"/>
-              <a:t>30/10/2021</a:t>
+              <a:t>23/06/2025</a:t>
             </a:fld>
             <a:endParaRPr lang="en-GB" dirty="0"/>
           </a:p>
@@ -2140,7 +2140,7 @@
           <a:p>
             <a:fld id="{28392D24-8B86-4B92-BF71-2898FDE196EB}" type="slidenum">
               <a:rPr lang="en-GB" smtClean="0"/>
-              <a:t>‹Nr.›</a:t>
+              <a:t>‹#›</a:t>
             </a:fld>
             <a:endParaRPr lang="en-GB" dirty="0"/>
           </a:p>
@@ -2201,7 +2201,7 @@
           </a:lstStyle>
           <a:p>
             <a:r>
-              <a:rPr lang="de-DE" smtClean="0"/>
+              <a:rPr lang="de-DE"/>
               <a:t>Titelmasterformat durch Klicken bearbeiten</a:t>
             </a:r>
             <a:endParaRPr lang="en-GB"/>
@@ -2328,7 +2328,7 @@
           <a:p>
             <a:pPr lvl="0"/>
             <a:r>
-              <a:rPr lang="de-DE" smtClean="0"/>
+              <a:rPr lang="de-DE"/>
               <a:t>Textmasterformat bearbeiten</a:t>
             </a:r>
           </a:p>
@@ -2351,7 +2351,7 @@
           <a:p>
             <a:fld id="{3FB75DC4-049D-4A9B-B286-BF003F86F273}" type="datetimeFigureOut">
               <a:rPr lang="en-GB" smtClean="0"/>
-              <a:t>30/10/2021</a:t>
+              <a:t>23/06/2025</a:t>
             </a:fld>
             <a:endParaRPr lang="en-GB" dirty="0"/>
           </a:p>
@@ -2393,7 +2393,7 @@
           <a:p>
             <a:fld id="{28392D24-8B86-4B92-BF71-2898FDE196EB}" type="slidenum">
               <a:rPr lang="en-GB" smtClean="0"/>
-              <a:t>‹Nr.›</a:t>
+              <a:t>‹#›</a:t>
             </a:fld>
             <a:endParaRPr lang="en-GB" dirty="0"/>
           </a:p>
@@ -2460,7 +2460,7 @@
           <a:lstStyle/>
           <a:p>
             <a:r>
-              <a:rPr lang="de-DE" smtClean="0"/>
+              <a:rPr lang="de-DE"/>
               <a:t>Titelmasterformat durch Klicken bearbeiten</a:t>
             </a:r>
             <a:endParaRPr lang="en-GB"/>
@@ -2494,35 +2494,35 @@
           <a:p>
             <a:pPr lvl="0"/>
             <a:r>
-              <a:rPr lang="de-DE" smtClean="0"/>
+              <a:rPr lang="de-DE"/>
               <a:t>Textmasterformat bearbeiten</a:t>
             </a:r>
           </a:p>
           <a:p>
             <a:pPr lvl="1"/>
             <a:r>
-              <a:rPr lang="de-DE" smtClean="0"/>
+              <a:rPr lang="de-DE"/>
               <a:t>Zweite Ebene</a:t>
             </a:r>
           </a:p>
           <a:p>
             <a:pPr lvl="2"/>
             <a:r>
-              <a:rPr lang="de-DE" smtClean="0"/>
+              <a:rPr lang="de-DE"/>
               <a:t>Dritte Ebene</a:t>
             </a:r>
           </a:p>
           <a:p>
             <a:pPr lvl="3"/>
             <a:r>
-              <a:rPr lang="de-DE" smtClean="0"/>
+              <a:rPr lang="de-DE"/>
               <a:t>Vierte Ebene</a:t>
             </a:r>
           </a:p>
           <a:p>
             <a:pPr lvl="4"/>
             <a:r>
-              <a:rPr lang="de-DE" smtClean="0"/>
+              <a:rPr lang="de-DE"/>
               <a:t>Fünfte Ebene</a:t>
             </a:r>
             <a:endParaRPr lang="en-GB"/>
@@ -2564,7 +2564,7 @@
           <a:p>
             <a:fld id="{3FB75DC4-049D-4A9B-B286-BF003F86F273}" type="datetimeFigureOut">
               <a:rPr lang="en-GB" smtClean="0"/>
-              <a:t>30/10/2021</a:t>
+              <a:t>23/06/2025</a:t>
             </a:fld>
             <a:endParaRPr lang="en-GB" dirty="0"/>
           </a:p>
@@ -2642,7 +2642,7 @@
           <a:p>
             <a:fld id="{28392D24-8B86-4B92-BF71-2898FDE196EB}" type="slidenum">
               <a:rPr lang="en-GB" smtClean="0"/>
-              <a:t>‹Nr.›</a:t>
+              <a:t>‹#›</a:t>
             </a:fld>
             <a:endParaRPr lang="en-GB" dirty="0"/>
           </a:p>
@@ -3074,7 +3074,7 @@
           <a:lstStyle/>
           <a:p>
             <a:r>
-              <a:rPr lang="de-DE" sz="800" dirty="0" smtClean="0">
+              <a:rPr lang="de-DE" sz="800" dirty="0">
                 <a:solidFill>
                   <a:schemeClr val="bg1"/>
                 </a:solidFill>
@@ -3091,7 +3091,7 @@
       </p:sp>
       <p:pic>
         <p:nvPicPr>
-          <p:cNvPr id="1034" name="Picture 10" descr="Bild"/>
+          <p:cNvPr id="1034" name="Picture 10"/>
           <p:cNvPicPr>
             <a:picLocks noChangeAspect="1" noChangeArrowheads="1"/>
           </p:cNvPicPr>
@@ -3106,9 +3106,7 @@
             </a:extLst>
           </a:blip>
           <a:srcRect/>
-          <a:stretch>
-            <a:fillRect/>
-          </a:stretch>
+          <a:stretch/>
         </p:blipFill>
         <p:spPr bwMode="auto">
           <a:xfrm>
@@ -3119,15 +3117,6 @@
             <a:avLst/>
           </a:prstGeom>
           <a:noFill/>
-          <a:extLst>
-            <a:ext uri="{909E8E84-426E-40DD-AFC4-6F175D3DCCD1}">
-              <a14:hiddenFill xmlns:a14="http://schemas.microsoft.com/office/drawing/2010/main">
-                <a:solidFill>
-                  <a:srgbClr val="FFFFFF"/>
-                </a:solidFill>
-              </a14:hiddenFill>
-            </a:ext>
-          </a:extLst>
         </p:spPr>
       </p:pic>
       <p:sp>
@@ -3153,7 +3142,7 @@
           <a:lstStyle/>
           <a:p>
             <a:r>
-              <a:rPr lang="de-DE" sz="800" dirty="0" smtClean="0">
+              <a:rPr lang="de-DE" sz="800" dirty="0">
                 <a:solidFill>
                   <a:schemeClr val="bg1"/>
                 </a:solidFill>
@@ -3191,7 +3180,7 @@
           <a:lstStyle/>
           <a:p>
             <a:r>
-              <a:rPr lang="de-DE" sz="800" dirty="0" smtClean="0">
+              <a:rPr lang="de-DE" sz="800" dirty="0">
                 <a:solidFill>
                   <a:schemeClr val="bg1"/>
                 </a:solidFill>
@@ -3270,7 +3259,7 @@
           <a:lstStyle/>
           <a:p>
             <a:r>
-              <a:rPr lang="de-DE" sz="800" dirty="0" smtClean="0">
+              <a:rPr lang="de-DE" sz="800" dirty="0">
                 <a:solidFill>
                   <a:schemeClr val="bg1"/>
                 </a:solidFill>
@@ -3308,7 +3297,7 @@
           <a:lstStyle/>
           <a:p>
             <a:r>
-              <a:rPr lang="de-DE" sz="800" dirty="0" smtClean="0">
+              <a:rPr lang="de-DE" sz="800" dirty="0">
                 <a:solidFill>
                   <a:schemeClr val="bg1"/>
                 </a:solidFill>
@@ -3592,7 +3581,7 @@
           <a:lstStyle/>
           <a:p>
             <a:r>
-              <a:rPr lang="de-DE" sz="1100" dirty="0" smtClean="0">
+              <a:rPr lang="de-DE" sz="1100" dirty="0">
                 <a:solidFill>
                   <a:schemeClr val="bg1"/>
                 </a:solidFill>
@@ -3703,7 +3692,7 @@
           <a:p>
             <a:pPr algn="ctr"/>
             <a:r>
-              <a:rPr lang="de-DE" sz="800" dirty="0" smtClean="0">
+              <a:rPr lang="de-DE" sz="800" dirty="0">
                 <a:solidFill>
                   <a:schemeClr val="bg1"/>
                 </a:solidFill>
@@ -3714,18 +3703,13 @@
           <a:p>
             <a:pPr algn="ctr"/>
             <a:r>
-              <a:rPr lang="de-DE" sz="800" dirty="0" smtClean="0">
+              <a:rPr lang="de-DE" sz="800" dirty="0">
                 <a:solidFill>
                   <a:schemeClr val="bg1"/>
                 </a:solidFill>
               </a:rPr>
               <a:t>Version or Plugin</a:t>
             </a:r>
-            <a:endParaRPr lang="de-DE" sz="800" dirty="0">
-              <a:solidFill>
-                <a:schemeClr val="bg1"/>
-              </a:solidFill>
-            </a:endParaRPr>
           </a:p>
           <a:p>
             <a:pPr algn="ctr"/>
@@ -3735,15 +3719,7 @@
                   <a:schemeClr val="bg1"/>
                 </a:solidFill>
               </a:rPr>
-              <a:t>U</a:t>
-            </a:r>
-            <a:r>
-              <a:rPr lang="de-DE" sz="800" dirty="0" smtClean="0">
-                <a:solidFill>
-                  <a:schemeClr val="bg1"/>
-                </a:solidFill>
-              </a:rPr>
-              <a:t>pdates</a:t>
+              <a:t>Updates</a:t>
             </a:r>
             <a:endParaRPr lang="en-GB" sz="1000" dirty="0">
               <a:solidFill>
@@ -3877,7 +3853,7 @@
           <a:lstStyle/>
           <a:p>
             <a:r>
-              <a:rPr lang="de-DE" sz="800" dirty="0" smtClean="0">
+              <a:rPr lang="de-DE" sz="800" dirty="0">
                 <a:solidFill>
                   <a:schemeClr val="bg1"/>
                 </a:solidFill>
@@ -3915,7 +3891,7 @@
           <a:lstStyle/>
           <a:p>
             <a:r>
-              <a:rPr lang="de-DE" sz="800" dirty="0" smtClean="0">
+              <a:rPr lang="de-DE" sz="800" dirty="0">
                 <a:solidFill>
                   <a:schemeClr val="bg1"/>
                 </a:solidFill>
@@ -3994,7 +3970,7 @@
           <a:lstStyle/>
           <a:p>
             <a:r>
-              <a:rPr lang="de-DE" sz="800" dirty="0" smtClean="0">
+              <a:rPr lang="de-DE" sz="800" dirty="0">
                 <a:solidFill>
                   <a:schemeClr val="bg1"/>
                 </a:solidFill>
@@ -4068,7 +4044,7 @@
           <a:lstStyle/>
           <a:p>
             <a:r>
-              <a:rPr lang="de-DE" sz="800" dirty="0" smtClean="0">
+              <a:rPr lang="de-DE" sz="800" dirty="0">
                 <a:solidFill>
                   <a:schemeClr val="bg1"/>
                 </a:solidFill>
@@ -4147,7 +4123,7 @@
           <a:lstStyle/>
           <a:p>
             <a:r>
-              <a:rPr lang="de-DE" sz="800" dirty="0" smtClean="0">
+              <a:rPr lang="de-DE" sz="800" dirty="0">
                 <a:solidFill>
                   <a:schemeClr val="bg1"/>
                 </a:solidFill>
@@ -4320,7 +4296,7 @@
         <p:spPr>
           <a:xfrm>
             <a:off x="3359674" y="5124451"/>
-            <a:ext cx="1034257" cy="215444"/>
+            <a:ext cx="1808508" cy="246221"/>
           </a:xfrm>
           <a:prstGeom prst="rect">
             <a:avLst/>
@@ -4334,18 +4310,13 @@
           <a:lstStyle/>
           <a:p>
             <a:r>
-              <a:rPr lang="de-DE" sz="800" dirty="0" smtClean="0">
+              <a:rPr lang="en-GB" sz="1000" dirty="0">
                 <a:solidFill>
                   <a:schemeClr val="bg1"/>
                 </a:solidFill>
               </a:rPr>
-              <a:t>Manual deployment</a:t>
-            </a:r>
-            <a:endParaRPr lang="en-GB" sz="800" dirty="0">
-              <a:solidFill>
-                <a:schemeClr val="bg1"/>
-              </a:solidFill>
-            </a:endParaRPr>
+              <a:t>Automated staged deployment</a:t>
+            </a:r>
           </a:p>
         </p:txBody>
       </p:sp>
@@ -4394,7 +4365,7 @@
         <p:spPr>
           <a:xfrm>
             <a:off x="4576735" y="2458516"/>
-            <a:ext cx="623889" cy="215444"/>
+            <a:ext cx="1808508" cy="246221"/>
           </a:xfrm>
           <a:prstGeom prst="rect">
             <a:avLst/>
@@ -4408,18 +4379,13 @@
           <a:lstStyle/>
           <a:p>
             <a:r>
-              <a:rPr lang="de-DE" sz="800" dirty="0" smtClean="0">
+              <a:rPr lang="en-GB" sz="1000" dirty="0">
                 <a:solidFill>
                   <a:schemeClr val="bg1"/>
                 </a:solidFill>
               </a:rPr>
-              <a:t>CI Pipeline</a:t>
-            </a:r>
-            <a:endParaRPr lang="en-GB" sz="1000" dirty="0">
-              <a:solidFill>
-                <a:schemeClr val="bg1"/>
-              </a:solidFill>
-            </a:endParaRPr>
+              <a:t>Automated staged deployment</a:t>
+            </a:r>
           </a:p>
         </p:txBody>
       </p:sp>
@@ -4657,7 +4623,7 @@
           <a:lstStyle/>
           <a:p>
             <a:r>
-              <a:rPr lang="de-DE" sz="800" dirty="0" smtClean="0">
+              <a:rPr lang="de-DE" sz="800" dirty="0">
                 <a:solidFill>
                   <a:schemeClr val="bg1"/>
                 </a:solidFill>
@@ -4767,7 +4733,7 @@
           <a:p>
             <a:pPr algn="ctr"/>
             <a:r>
-              <a:rPr lang="de-DE" sz="800" dirty="0" smtClean="0">
+              <a:rPr lang="de-DE" sz="800" dirty="0">
                 <a:solidFill>
                   <a:schemeClr val="bg1"/>
                 </a:solidFill>
@@ -4778,7 +4744,7 @@
           <a:p>
             <a:pPr algn="ctr"/>
             <a:r>
-              <a:rPr lang="de-DE" sz="800" dirty="0" smtClean="0">
+              <a:rPr lang="de-DE" sz="800" dirty="0">
                 <a:solidFill>
                   <a:schemeClr val="bg1"/>
                 </a:solidFill>
@@ -4924,7 +4890,7 @@
           <a:p>
             <a:pPr algn="ctr"/>
             <a:r>
-              <a:rPr lang="de-DE" sz="800" dirty="0" smtClean="0">
+              <a:rPr lang="de-DE" sz="800" dirty="0">
                 <a:solidFill>
                   <a:schemeClr val="bg1"/>
                 </a:solidFill>
@@ -4935,7 +4901,7 @@
           <a:p>
             <a:pPr algn="ctr"/>
             <a:r>
-              <a:rPr lang="de-DE" sz="800" dirty="0" smtClean="0">
+              <a:rPr lang="de-DE" sz="800" dirty="0">
                 <a:solidFill>
                   <a:schemeClr val="bg1"/>
                 </a:solidFill>
@@ -4973,7 +4939,7 @@
           <a:lstStyle/>
           <a:p>
             <a:r>
-              <a:rPr lang="de-DE" sz="800" dirty="0" smtClean="0">
+              <a:rPr lang="de-DE" sz="800" dirty="0">
                 <a:solidFill>
                   <a:schemeClr val="bg1"/>
                 </a:solidFill>
@@ -5011,7 +4977,7 @@
           <a:lstStyle/>
           <a:p>
             <a:r>
-              <a:rPr lang="de-DE" sz="800" dirty="0" smtClean="0">
+              <a:rPr lang="de-DE" sz="800" dirty="0">
                 <a:solidFill>
                   <a:schemeClr val="bg1"/>
                 </a:solidFill>
@@ -5049,7 +5015,7 @@
           <a:lstStyle/>
           <a:p>
             <a:r>
-              <a:rPr lang="de-DE" sz="800" dirty="0" smtClean="0">
+              <a:rPr lang="de-DE" sz="800" dirty="0">
                 <a:solidFill>
                   <a:schemeClr val="bg1"/>
                 </a:solidFill>
@@ -5087,7 +5053,7 @@
           <a:lstStyle/>
           <a:p>
             <a:r>
-              <a:rPr lang="de-DE" sz="800" dirty="0" smtClean="0">
+              <a:rPr lang="de-DE" sz="800" dirty="0">
                 <a:solidFill>
                   <a:schemeClr val="bg1"/>
                 </a:solidFill>
@@ -5192,7 +5158,7 @@
           <a:p>
             <a:pPr algn="ctr"/>
             <a:r>
-              <a:rPr lang="de-DE" sz="800" dirty="0" smtClean="0">
+              <a:rPr lang="de-DE" sz="800" dirty="0">
                 <a:solidFill>
                   <a:schemeClr val="bg1"/>
                 </a:solidFill>
@@ -5203,7 +5169,7 @@
           <a:p>
             <a:pPr algn="ctr"/>
             <a:r>
-              <a:rPr lang="de-DE" sz="800" dirty="0" smtClean="0">
+              <a:rPr lang="de-DE" sz="800" dirty="0">
                 <a:solidFill>
                   <a:schemeClr val="bg1"/>
                 </a:solidFill>
@@ -5346,7 +5312,7 @@
           <a:p>
             <a:pPr algn="ctr"/>
             <a:r>
-              <a:rPr lang="de-DE" sz="800" dirty="0" smtClean="0">
+              <a:rPr lang="de-DE" sz="800" dirty="0">
                 <a:solidFill>
                   <a:schemeClr val="bg1"/>
                 </a:solidFill>
@@ -5357,7 +5323,7 @@
           <a:p>
             <a:pPr algn="ctr"/>
             <a:r>
-              <a:rPr lang="de-DE" sz="800" dirty="0" smtClean="0">
+              <a:rPr lang="de-DE" sz="800" dirty="0">
                 <a:solidFill>
                   <a:schemeClr val="bg1"/>
                 </a:solidFill>
@@ -5632,7 +5598,7 @@
         <p:spPr>
           <a:xfrm>
             <a:off x="1541578" y="3773808"/>
-            <a:ext cx="728084" cy="261610"/>
+            <a:ext cx="574196" cy="261610"/>
           </a:xfrm>
           <a:prstGeom prst="rect">
             <a:avLst/>
@@ -5646,12 +5612,12 @@
           <a:lstStyle/>
           <a:p>
             <a:r>
-              <a:rPr lang="de-DE" sz="1100" dirty="0" smtClean="0">
+              <a:rPr lang="de-DE" sz="1100" dirty="0">
                 <a:solidFill>
                   <a:schemeClr val="bg1"/>
                 </a:solidFill>
               </a:rPr>
-              <a:t>Bitbucket</a:t>
+              <a:t>Github</a:t>
             </a:r>
             <a:endParaRPr lang="en-GB" sz="1400" dirty="0">
               <a:solidFill>
@@ -5762,7 +5728,7 @@
           <a:lstStyle/>
           <a:p>
             <a:r>
-              <a:rPr lang="de-DE" sz="800" dirty="0" smtClean="0">
+              <a:rPr lang="de-DE" sz="800" dirty="0">
                 <a:solidFill>
                   <a:schemeClr val="bg1"/>
                 </a:solidFill>
@@ -5800,7 +5766,7 @@
           <a:lstStyle/>
           <a:p>
             <a:r>
-              <a:rPr lang="de-DE" sz="800" dirty="0" smtClean="0">
+              <a:rPr lang="de-DE" sz="800" dirty="0">
                 <a:solidFill>
                   <a:schemeClr val="bg1"/>
                 </a:solidFill>
@@ -6043,7 +6009,7 @@
           <a:lstStyle/>
           <a:p>
             <a:r>
-              <a:rPr lang="de-DE" sz="800" dirty="0" smtClean="0">
+              <a:rPr lang="de-DE" sz="800" dirty="0">
                 <a:solidFill>
                   <a:schemeClr val="bg1"/>
                 </a:solidFill>
@@ -6119,7 +6085,7 @@
           <a:p>
             <a:pPr algn="ctr"/>
             <a:r>
-              <a:rPr lang="de-DE" sz="800" dirty="0" smtClean="0">
+              <a:rPr lang="de-DE" sz="800" dirty="0">
                 <a:solidFill>
                   <a:schemeClr val="bg1"/>
                 </a:solidFill>
@@ -6253,7 +6219,7 @@
           <a:lstStyle/>
           <a:p>
             <a:r>
-              <a:rPr lang="de-DE" sz="800" dirty="0" smtClean="0">
+              <a:rPr lang="de-DE" sz="800" dirty="0">
                 <a:solidFill>
                   <a:schemeClr val="bg1"/>
                 </a:solidFill>
@@ -6263,7 +6229,7 @@
           </a:p>
           <a:p>
             <a:r>
-              <a:rPr lang="de-DE" sz="800" dirty="0" smtClean="0">
+              <a:rPr lang="de-DE" sz="800" dirty="0">
                 <a:solidFill>
                   <a:schemeClr val="bg1"/>
                 </a:solidFill>
@@ -6301,7 +6267,7 @@
           <a:lstStyle/>
           <a:p>
             <a:r>
-              <a:rPr lang="de-DE" sz="2400" dirty="0" smtClean="0">
+              <a:rPr lang="de-DE" sz="2400" dirty="0">
                 <a:solidFill>
                   <a:schemeClr val="bg1"/>
                 </a:solidFill>
@@ -6544,7 +6510,7 @@
           <a:lstStyle/>
           <a:p>
             <a:r>
-              <a:rPr lang="de-DE" sz="800" dirty="0" smtClean="0">
+              <a:rPr lang="de-DE" sz="800" dirty="0">
                 <a:solidFill>
                   <a:schemeClr val="bg1"/>
                 </a:solidFill>
@@ -6620,7 +6586,7 @@
           <a:p>
             <a:pPr algn="ctr"/>
             <a:r>
-              <a:rPr lang="de-DE" sz="800" dirty="0" smtClean="0">
+              <a:rPr lang="de-DE" sz="800" dirty="0">
                 <a:solidFill>
                   <a:schemeClr val="bg1"/>
                 </a:solidFill>
@@ -6638,23 +6604,15 @@
               </a:rPr>
               <a:t>&amp;</a:t>
             </a:r>
-            <a:r>
-              <a:rPr lang="de-DE" sz="800" dirty="0" smtClean="0">
-                <a:solidFill>
-                  <a:schemeClr val="bg1"/>
-                </a:solidFill>
-              </a:rPr>
-              <a:t/>
-            </a:r>
             <a:br>
-              <a:rPr lang="de-DE" sz="800" dirty="0" smtClean="0">
+              <a:rPr lang="de-DE" sz="800" dirty="0">
                 <a:solidFill>
                   <a:schemeClr val="bg1"/>
                 </a:solidFill>
               </a:rPr>
             </a:br>
             <a:r>
-              <a:rPr lang="de-DE" sz="800" dirty="0" smtClean="0">
+              <a:rPr lang="de-DE" sz="800" dirty="0">
                 <a:solidFill>
                   <a:schemeClr val="bg1"/>
                 </a:solidFill>
@@ -6720,13 +6678,6 @@
   <p:clrMapOvr>
     <a:masterClrMapping/>
   </p:clrMapOvr>
-  <p:timing>
-    <p:tnLst>
-      <p:par>
-        <p:cTn id="1" dur="indefinite" restart="never" nodeType="tmRoot"/>
-      </p:par>
-    </p:tnLst>
-  </p:timing>
 </p:sld>
 </file>
 

</xml_diff>